<commit_message>
Added PPT and labels
</commit_message>
<xml_diff>
--- a/PromptWars_May2026/VoyageFlow_Presentation.pptx
+++ b/PromptWars_May2026/VoyageFlow_Presentation.pptx
@@ -3194,7 +3194,7 @@
           <a:p>
             <a:pPr>
               <a:spcBef>
-                <a:spcPts val="4000"/>
+                <a:spcPts val="3000"/>
               </a:spcBef>
               <a:defRPr sz="1400" i="1">
                 <a:solidFill>
@@ -3205,6 +3205,22 @@
             </a:pPr>
             <a:r>
               <a:t>Hosted fully Serverless in WebAssembly on Vercel Edge</a:t>
+            </a:r>
+          </a:p>
+          <a:p>
+            <a:pPr>
+              <a:spcBef>
+                <a:spcPts val="1000"/>
+              </a:spcBef>
+              <a:defRPr sz="1400" b="1">
+                <a:solidFill>
+                  <a:srgbClr val="FF9933"/>
+                </a:solidFill>
+                <a:latin typeface="Arial"/>
+              </a:defRPr>
+            </a:pPr>
+            <a:r>
+              <a:t>Prompt Wars May 2026 Submission by Ankit Mathur</a:t>
             </a:r>
           </a:p>
         </p:txBody>

</xml_diff>